<commit_message>
Signed-off-by: Kohsuke KISHIMOTO <kishimoto.research@gmail.com>
</commit_message>
<xml_diff>
--- a/progress/report_August2026/原稿関連/flow_of_funds.pptx
+++ b/progress/report_August2026/原稿関連/flow_of_funds.pptx
@@ -104,6 +104,11 @@
       </a:defRPr>
     </a:lvl9pPr>
   </p:defaultTextStyle>
+  <p:extLst>
+    <p:ext uri="{EFAFB233-063F-42B5-8137-9DF3F51BA10A}">
+      <p15:sldGuideLst xmlns:p15="http://schemas.microsoft.com/office/powerpoint/2012/main"/>
+    </p:ext>
+  </p:extLst>
 </p:presentation>
 </file>
 
@@ -254,7 +259,7 @@
           <a:p>
             <a:fld id="{FBCF5007-FE77-432E-8C7B-148C75EC50F6}" type="datetimeFigureOut">
               <a:rPr kumimoji="1" lang="ja-JP" altLang="en-US" smtClean="0"/>
-              <a:t>2026/7/31</a:t>
+              <a:t>2026/8/21</a:t>
             </a:fld>
             <a:endParaRPr kumimoji="1" lang="ja-JP" altLang="en-US"/>
           </a:p>
@@ -484,7 +489,7 @@
           <a:p>
             <a:fld id="{FBCF5007-FE77-432E-8C7B-148C75EC50F6}" type="datetimeFigureOut">
               <a:rPr kumimoji="1" lang="ja-JP" altLang="en-US" smtClean="0"/>
-              <a:t>2026/7/31</a:t>
+              <a:t>2026/8/21</a:t>
             </a:fld>
             <a:endParaRPr kumimoji="1" lang="ja-JP" altLang="en-US"/>
           </a:p>
@@ -724,7 +729,7 @@
           <a:p>
             <a:fld id="{FBCF5007-FE77-432E-8C7B-148C75EC50F6}" type="datetimeFigureOut">
               <a:rPr kumimoji="1" lang="ja-JP" altLang="en-US" smtClean="0"/>
-              <a:t>2026/7/31</a:t>
+              <a:t>2026/8/21</a:t>
             </a:fld>
             <a:endParaRPr kumimoji="1" lang="ja-JP" altLang="en-US"/>
           </a:p>
@@ -954,7 +959,7 @@
           <a:p>
             <a:fld id="{FBCF5007-FE77-432E-8C7B-148C75EC50F6}" type="datetimeFigureOut">
               <a:rPr kumimoji="1" lang="ja-JP" altLang="en-US" smtClean="0"/>
-              <a:t>2026/7/31</a:t>
+              <a:t>2026/8/21</a:t>
             </a:fld>
             <a:endParaRPr kumimoji="1" lang="ja-JP" altLang="en-US"/>
           </a:p>
@@ -1229,7 +1234,7 @@
           <a:p>
             <a:fld id="{FBCF5007-FE77-432E-8C7B-148C75EC50F6}" type="datetimeFigureOut">
               <a:rPr kumimoji="1" lang="ja-JP" altLang="en-US" smtClean="0"/>
-              <a:t>2026/7/31</a:t>
+              <a:t>2026/8/21</a:t>
             </a:fld>
             <a:endParaRPr kumimoji="1" lang="ja-JP" altLang="en-US"/>
           </a:p>
@@ -1558,7 +1563,7 @@
           <a:p>
             <a:fld id="{FBCF5007-FE77-432E-8C7B-148C75EC50F6}" type="datetimeFigureOut">
               <a:rPr kumimoji="1" lang="ja-JP" altLang="en-US" smtClean="0"/>
-              <a:t>2026/7/31</a:t>
+              <a:t>2026/8/21</a:t>
             </a:fld>
             <a:endParaRPr kumimoji="1" lang="ja-JP" altLang="en-US"/>
           </a:p>
@@ -2034,7 +2039,7 @@
           <a:p>
             <a:fld id="{FBCF5007-FE77-432E-8C7B-148C75EC50F6}" type="datetimeFigureOut">
               <a:rPr kumimoji="1" lang="ja-JP" altLang="en-US" smtClean="0"/>
-              <a:t>2026/7/31</a:t>
+              <a:t>2026/8/21</a:t>
             </a:fld>
             <a:endParaRPr kumimoji="1" lang="ja-JP" altLang="en-US"/>
           </a:p>
@@ -2175,7 +2180,7 @@
           <a:p>
             <a:fld id="{FBCF5007-FE77-432E-8C7B-148C75EC50F6}" type="datetimeFigureOut">
               <a:rPr kumimoji="1" lang="ja-JP" altLang="en-US" smtClean="0"/>
-              <a:t>2026/7/31</a:t>
+              <a:t>2026/8/21</a:t>
             </a:fld>
             <a:endParaRPr kumimoji="1" lang="ja-JP" altLang="en-US"/>
           </a:p>
@@ -2288,7 +2293,7 @@
           <a:p>
             <a:fld id="{FBCF5007-FE77-432E-8C7B-148C75EC50F6}" type="datetimeFigureOut">
               <a:rPr kumimoji="1" lang="ja-JP" altLang="en-US" smtClean="0"/>
-              <a:t>2026/7/31</a:t>
+              <a:t>2026/8/21</a:t>
             </a:fld>
             <a:endParaRPr kumimoji="1" lang="ja-JP" altLang="en-US"/>
           </a:p>
@@ -2631,7 +2636,7 @@
           <a:p>
             <a:fld id="{FBCF5007-FE77-432E-8C7B-148C75EC50F6}" type="datetimeFigureOut">
               <a:rPr kumimoji="1" lang="ja-JP" altLang="en-US" smtClean="0"/>
-              <a:t>2026/7/31</a:t>
+              <a:t>2026/8/21</a:t>
             </a:fld>
             <a:endParaRPr kumimoji="1" lang="ja-JP" altLang="en-US"/>
           </a:p>
@@ -2919,7 +2924,7 @@
           <a:p>
             <a:fld id="{FBCF5007-FE77-432E-8C7B-148C75EC50F6}" type="datetimeFigureOut">
               <a:rPr kumimoji="1" lang="ja-JP" altLang="en-US" smtClean="0"/>
-              <a:t>2026/7/31</a:t>
+              <a:t>2026/8/21</a:t>
             </a:fld>
             <a:endParaRPr kumimoji="1" lang="ja-JP" altLang="en-US"/>
           </a:p>
@@ -3192,7 +3197,7 @@
           <a:p>
             <a:fld id="{FBCF5007-FE77-432E-8C7B-148C75EC50F6}" type="datetimeFigureOut">
               <a:rPr kumimoji="1" lang="ja-JP" altLang="en-US" smtClean="0"/>
-              <a:t>2026/7/31</a:t>
+              <a:t>2026/8/21</a:t>
             </a:fld>
             <a:endParaRPr kumimoji="1" lang="ja-JP" altLang="en-US"/>
           </a:p>
@@ -4014,8 +4019,8 @@
           </a:p>
         </p:txBody>
       </p:sp>
-      <mc:AlternateContent xmlns:mc="http://schemas.openxmlformats.org/markup-compatibility/2006">
-        <mc:Choice xmlns:a14="http://schemas.microsoft.com/office/drawing/2010/main" Requires="a14">
+      <mc:AlternateContent xmlns:mc="http://schemas.openxmlformats.org/markup-compatibility/2006" xmlns:a14="http://schemas.microsoft.com/office/drawing/2010/main">
+        <mc:Choice Requires="a14">
           <p:sp>
             <p:nvSpPr>
               <p:cNvPr id="39" name="テキスト ボックス 38">
@@ -4044,12 +4049,10 @@
               </a:bodyPr>
               <a:lstStyle/>
               <a:p>
+                <a:pPr/>
                 <a14:m>
                   <m:oMathPara xmlns:m="http://schemas.openxmlformats.org/officeDocument/2006/math">
-                    <m:oMathParaPr>
-                      <m:jc m:val="centerGroup"/>
-                    </m:oMathParaPr>
-                    <m:oMath xmlns:m="http://schemas.openxmlformats.org/officeDocument/2006/math">
+                    <m:oMath>
                       <m:sSub>
                         <m:sSubPr>
                           <m:ctrlPr>
@@ -4108,7 +4111,7 @@
             </p:txBody>
           </p:sp>
         </mc:Choice>
-        <mc:Fallback>
+        <mc:Fallback xmlns="">
           <p:sp>
             <p:nvSpPr>
               <p:cNvPr id="39" name="テキスト ボックス 38">
@@ -4153,8 +4156,8 @@
           </p:sp>
         </mc:Fallback>
       </mc:AlternateContent>
-      <mc:AlternateContent xmlns:mc="http://schemas.openxmlformats.org/markup-compatibility/2006">
-        <mc:Choice xmlns:a14="http://schemas.microsoft.com/office/drawing/2010/main" Requires="a14">
+      <mc:AlternateContent xmlns:mc="http://schemas.openxmlformats.org/markup-compatibility/2006" xmlns:a14="http://schemas.microsoft.com/office/drawing/2010/main">
+        <mc:Choice Requires="a14">
           <p:sp>
             <p:nvSpPr>
               <p:cNvPr id="41" name="テキスト ボックス 40">
@@ -4183,12 +4186,10 @@
               </a:bodyPr>
               <a:lstStyle/>
               <a:p>
+                <a:pPr/>
                 <a14:m>
                   <m:oMathPara xmlns:m="http://schemas.openxmlformats.org/officeDocument/2006/math">
-                    <m:oMathParaPr>
-                      <m:jc m:val="centerGroup"/>
-                    </m:oMathParaPr>
-                    <m:oMath xmlns:m="http://schemas.openxmlformats.org/officeDocument/2006/math">
+                    <m:oMath>
                       <m:sSubSup>
                         <m:sSubSupPr>
                           <m:ctrlPr>
@@ -4263,7 +4264,7 @@
             </p:txBody>
           </p:sp>
         </mc:Choice>
-        <mc:Fallback>
+        <mc:Fallback xmlns="">
           <p:sp>
             <p:nvSpPr>
               <p:cNvPr id="41" name="テキスト ボックス 40">
@@ -4308,8 +4309,8 @@
           </p:sp>
         </mc:Fallback>
       </mc:AlternateContent>
-      <mc:AlternateContent xmlns:mc="http://schemas.openxmlformats.org/markup-compatibility/2006">
-        <mc:Choice xmlns:a14="http://schemas.microsoft.com/office/drawing/2010/main" Requires="a14">
+      <mc:AlternateContent xmlns:mc="http://schemas.openxmlformats.org/markup-compatibility/2006" xmlns:a14="http://schemas.microsoft.com/office/drawing/2010/main">
+        <mc:Choice Requires="a14">
           <p:sp>
             <p:nvSpPr>
               <p:cNvPr id="42" name="テキスト ボックス 41">
@@ -4338,12 +4339,10 @@
               </a:bodyPr>
               <a:lstStyle/>
               <a:p>
+                <a:pPr/>
                 <a14:m>
                   <m:oMathPara xmlns:m="http://schemas.openxmlformats.org/officeDocument/2006/math">
-                    <m:oMathParaPr>
-                      <m:jc m:val="centerGroup"/>
-                    </m:oMathParaPr>
-                    <m:oMath xmlns:m="http://schemas.openxmlformats.org/officeDocument/2006/math">
+                    <m:oMath>
                       <m:sSubSup>
                         <m:sSubSupPr>
                           <m:ctrlPr>
@@ -4385,7 +4384,7 @@
             </p:txBody>
           </p:sp>
         </mc:Choice>
-        <mc:Fallback>
+        <mc:Fallback xmlns="">
           <p:sp>
             <p:nvSpPr>
               <p:cNvPr id="42" name="テキスト ボックス 41">
@@ -4446,8 +4445,8 @@
             </p:nvSpPr>
             <p:spPr>
               <a:xfrm>
-                <a:off x="7968393" y="1420749"/>
-                <a:ext cx="886205" cy="369332"/>
+                <a:off x="7343742" y="1460385"/>
+                <a:ext cx="2132635" cy="738664"/>
               </a:xfrm>
               <a:prstGeom prst="rect">
                 <a:avLst/>
@@ -4460,26 +4459,24 @@
               </a:bodyPr>
               <a:lstStyle/>
               <a:p>
+                <a:pPr/>
                 <a14:m>
                   <m:oMathPara xmlns:m="http://schemas.openxmlformats.org/officeDocument/2006/math">
-                    <m:oMathParaPr>
-                      <m:jc m:val="centerGroup"/>
-                    </m:oMathParaPr>
-                    <m:oMath xmlns:m="http://schemas.openxmlformats.org/officeDocument/2006/math">
+                    <m:oMath>
                       <m:r>
                         <a:rPr kumimoji="1" lang="en-US" altLang="ja-JP" sz="2400" b="0" i="1" smtClean="0">
                           <a:latin typeface="Cambria Math" panose="02040503050406030204" pitchFamily="18" charset="0"/>
                         </a:rPr>
                         <m:t>𝜔</m:t>
                       </m:r>
-                      <m:sSub>
-                        <m:sSubPr>
+                      <m:sSubSup>
+                        <m:sSubSupPr>
                           <m:ctrlPr>
                             <a:rPr kumimoji="1" lang="en-US" altLang="ja-JP" sz="2400" b="0" i="1" smtClean="0">
                               <a:latin typeface="Cambria Math" panose="02040503050406030204" pitchFamily="18" charset="0"/>
                             </a:rPr>
                           </m:ctrlPr>
-                        </m:sSubPr>
+                        </m:sSubSupPr>
                         <m:e>
                           <m:r>
                             <a:rPr kumimoji="1" lang="en-US" altLang="ja-JP" sz="2400" b="0" i="1" smtClean="0">
@@ -4502,10 +4499,22 @@
                             <m:t>−1</m:t>
                           </m:r>
                         </m:sub>
-                      </m:sSub>
+                        <m:sup>
+                          <m:r>
+                            <a:rPr kumimoji="1" lang="en-US" altLang="ja-JP" sz="2400" b="0" i="1" smtClean="0">
+                              <a:latin typeface="Cambria Math" panose="02040503050406030204" pitchFamily="18" charset="0"/>
+                            </a:rPr>
+                            <m:t>′</m:t>
+                          </m:r>
+                        </m:sup>
+                      </m:sSubSup>
                     </m:oMath>
                   </m:oMathPara>
                 </a14:m>
+                <a:endParaRPr kumimoji="1" lang="en-US" altLang="ja-JP" sz="2400" b="0" dirty="0"/>
+              </a:p>
+              <a:p>
+                <a:pPr/>
                 <a:endParaRPr kumimoji="1" lang="en-US" altLang="ja-JP" sz="2400" b="0" dirty="0"/>
               </a:p>
             </p:txBody>
@@ -4528,8 +4537,8 @@
             </p:nvSpPr>
             <p:spPr>
               <a:xfrm>
-                <a:off x="7968393" y="1420749"/>
-                <a:ext cx="886205" cy="369332"/>
+                <a:off x="7343742" y="1460385"/>
+                <a:ext cx="2132635" cy="738664"/>
               </a:xfrm>
               <a:prstGeom prst="rect">
                 <a:avLst/>
@@ -4537,7 +4546,7 @@
               <a:blipFill>
                 <a:blip r:embed="rId5"/>
                 <a:stretch>
-                  <a:fillRect l="-2740" r="-1370" b="-11475"/>
+                  <a:fillRect/>
                 </a:stretch>
               </a:blipFill>
             </p:spPr>
@@ -4556,151 +4565,8 @@
           </p:sp>
         </mc:Fallback>
       </mc:AlternateContent>
-      <mc:AlternateContent xmlns:mc="http://schemas.openxmlformats.org/markup-compatibility/2006">
-        <mc:Choice xmlns:a14="http://schemas.microsoft.com/office/drawing/2010/main" Requires="a14">
-          <p:sp>
-            <p:nvSpPr>
-              <p:cNvPr id="45" name="テキスト ボックス 44">
-                <a:extLst>
-                  <a:ext uri="{FF2B5EF4-FFF2-40B4-BE49-F238E27FC236}">
-                    <a16:creationId xmlns:a16="http://schemas.microsoft.com/office/drawing/2014/main" id="{7F603C6D-FBE8-4258-80E2-AB0D7804021D}"/>
-                  </a:ext>
-                </a:extLst>
-              </p:cNvPr>
-              <p:cNvSpPr txBox="1"/>
-              <p:nvPr/>
-            </p:nvSpPr>
-            <p:spPr>
-              <a:xfrm>
-                <a:off x="7542289" y="4409762"/>
-                <a:ext cx="1630254" cy="369332"/>
-              </a:xfrm>
-              <a:prstGeom prst="rect">
-                <a:avLst/>
-              </a:prstGeom>
-              <a:noFill/>
-            </p:spPr>
-            <p:txBody>
-              <a:bodyPr wrap="none" lIns="0" tIns="0" rIns="0" bIns="0" rtlCol="0">
-                <a:spAutoFit/>
-              </a:bodyPr>
-              <a:lstStyle/>
-              <a:p>
-                <a14:m>
-                  <m:oMathPara xmlns:m="http://schemas.openxmlformats.org/officeDocument/2006/math">
-                    <m:oMathParaPr>
-                      <m:jc m:val="centerGroup"/>
-                    </m:oMathParaPr>
-                    <m:oMath xmlns:m="http://schemas.openxmlformats.org/officeDocument/2006/math">
-                      <m:d>
-                        <m:dPr>
-                          <m:ctrlPr>
-                            <a:rPr kumimoji="1" lang="en-US" altLang="ja-JP" sz="2400" b="0" i="1" smtClean="0">
-                              <a:latin typeface="Cambria Math" panose="02040503050406030204" pitchFamily="18" charset="0"/>
-                            </a:rPr>
-                          </m:ctrlPr>
-                        </m:dPr>
-                        <m:e>
-                          <m:r>
-                            <a:rPr kumimoji="1" lang="en-US" altLang="ja-JP" sz="2400" b="0" i="1" smtClean="0">
-                              <a:latin typeface="Cambria Math" panose="02040503050406030204" pitchFamily="18" charset="0"/>
-                            </a:rPr>
-                            <m:t>1−</m:t>
-                          </m:r>
-                          <m:r>
-                            <a:rPr kumimoji="1" lang="en-US" altLang="ja-JP" sz="2400" b="0" i="1" smtClean="0">
-                              <a:latin typeface="Cambria Math" panose="02040503050406030204" pitchFamily="18" charset="0"/>
-                            </a:rPr>
-                            <m:t>𝜃</m:t>
-                          </m:r>
-                        </m:e>
-                      </m:d>
-                      <m:sSub>
-                        <m:sSubPr>
-                          <m:ctrlPr>
-                            <a:rPr kumimoji="1" lang="en-US" altLang="ja-JP" sz="2400" b="0" i="1" smtClean="0">
-                              <a:latin typeface="Cambria Math" panose="02040503050406030204" pitchFamily="18" charset="0"/>
-                            </a:rPr>
-                          </m:ctrlPr>
-                        </m:sSubPr>
-                        <m:e>
-                          <m:r>
-                            <a:rPr kumimoji="1" lang="en-US" altLang="ja-JP" sz="2400" b="0" i="1" smtClean="0">
-                              <a:latin typeface="Cambria Math" panose="02040503050406030204" pitchFamily="18" charset="0"/>
-                            </a:rPr>
-                            <m:t>𝑏</m:t>
-                          </m:r>
-                        </m:e>
-                        <m:sub>
-                          <m:r>
-                            <a:rPr kumimoji="1" lang="en-US" altLang="ja-JP" sz="2400" b="0" i="1" smtClean="0">
-                              <a:latin typeface="Cambria Math" panose="02040503050406030204" pitchFamily="18" charset="0"/>
-                            </a:rPr>
-                            <m:t>𝑡</m:t>
-                          </m:r>
-                          <m:r>
-                            <a:rPr kumimoji="1" lang="en-US" altLang="ja-JP" sz="2400" b="0" i="1" smtClean="0">
-                              <a:latin typeface="Cambria Math" panose="02040503050406030204" pitchFamily="18" charset="0"/>
-                            </a:rPr>
-                            <m:t>−1</m:t>
-                          </m:r>
-                        </m:sub>
-                      </m:sSub>
-                    </m:oMath>
-                  </m:oMathPara>
-                </a14:m>
-                <a:endParaRPr kumimoji="1" lang="en-US" altLang="ja-JP" b="0" dirty="0"/>
-              </a:p>
-            </p:txBody>
-          </p:sp>
-        </mc:Choice>
-        <mc:Fallback>
-          <p:sp>
-            <p:nvSpPr>
-              <p:cNvPr id="45" name="テキスト ボックス 44">
-                <a:extLst>
-                  <a:ext uri="{FF2B5EF4-FFF2-40B4-BE49-F238E27FC236}">
-                    <a16:creationId xmlns:a16="http://schemas.microsoft.com/office/drawing/2014/main" id="{7F603C6D-FBE8-4258-80E2-AB0D7804021D}"/>
-                  </a:ext>
-                </a:extLst>
-              </p:cNvPr>
-              <p:cNvSpPr txBox="1">
-                <a:spLocks noRot="1" noChangeAspect="1" noMove="1" noResize="1" noEditPoints="1" noAdjustHandles="1" noChangeArrowheads="1" noChangeShapeType="1" noTextEdit="1"/>
-              </p:cNvSpPr>
-              <p:nvPr/>
-            </p:nvSpPr>
-            <p:spPr>
-              <a:xfrm>
-                <a:off x="7542289" y="4409762"/>
-                <a:ext cx="1630254" cy="369332"/>
-              </a:xfrm>
-              <a:prstGeom prst="rect">
-                <a:avLst/>
-              </a:prstGeom>
-              <a:blipFill>
-                <a:blip r:embed="rId6"/>
-                <a:stretch>
-                  <a:fillRect r="-373" b="-11475"/>
-                </a:stretch>
-              </a:blipFill>
-            </p:spPr>
-            <p:txBody>
-              <a:bodyPr/>
-              <a:lstStyle/>
-              <a:p>
-                <a:r>
-                  <a:rPr lang="ja-JP" altLang="en-US">
-                    <a:noFill/>
-                  </a:rPr>
-                  <a:t> </a:t>
-                </a:r>
-              </a:p>
-            </p:txBody>
-          </p:sp>
-        </mc:Fallback>
-      </mc:AlternateContent>
-      <mc:AlternateContent xmlns:mc="http://schemas.openxmlformats.org/markup-compatibility/2006">
-        <mc:Choice xmlns:a14="http://schemas.microsoft.com/office/drawing/2010/main" Requires="a14">
+      <mc:AlternateContent xmlns:mc="http://schemas.openxmlformats.org/markup-compatibility/2006" xmlns:a14="http://schemas.microsoft.com/office/drawing/2010/main">
+        <mc:Choice Requires="a14">
           <p:sp>
             <p:nvSpPr>
               <p:cNvPr id="47" name="テキスト ボックス 46">
@@ -4732,10 +4598,7 @@
                 <a:pPr/>
                 <a14:m>
                   <m:oMathPara xmlns:m="http://schemas.openxmlformats.org/officeDocument/2006/math">
-                    <m:oMathParaPr>
-                      <m:jc m:val="centerGroup"/>
-                    </m:oMathParaPr>
-                    <m:oMath xmlns:m="http://schemas.openxmlformats.org/officeDocument/2006/math">
+                    <m:oMath>
                       <m:sSub>
                         <m:sSubPr>
                           <m:ctrlPr>
@@ -4769,7 +4632,7 @@
             </p:txBody>
           </p:sp>
         </mc:Choice>
-        <mc:Fallback>
+        <mc:Fallback xmlns="">
           <p:sp>
             <p:nvSpPr>
               <p:cNvPr id="47" name="テキスト ボックス 46">
@@ -4943,6 +4806,307 @@
           </a:p>
         </p:txBody>
       </p:sp>
+      <mc:AlternateContent xmlns:mc="http://schemas.openxmlformats.org/markup-compatibility/2006">
+        <mc:Choice xmlns:a14="http://schemas.microsoft.com/office/drawing/2010/main" Requires="a14">
+          <p:sp>
+            <p:nvSpPr>
+              <p:cNvPr id="2" name="テキスト ボックス 1">
+                <a:extLst>
+                  <a:ext uri="{FF2B5EF4-FFF2-40B4-BE49-F238E27FC236}">
+                    <a16:creationId xmlns:a16="http://schemas.microsoft.com/office/drawing/2014/main" id="{ECCC5459-23EA-3FBF-3252-BF94DE2A3259}"/>
+                  </a:ext>
+                </a:extLst>
+              </p:cNvPr>
+              <p:cNvSpPr txBox="1"/>
+              <p:nvPr/>
+            </p:nvSpPr>
+            <p:spPr>
+              <a:xfrm>
+                <a:off x="6385915" y="4375352"/>
+                <a:ext cx="3943002" cy="1199174"/>
+              </a:xfrm>
+              <a:prstGeom prst="rect">
+                <a:avLst/>
+              </a:prstGeom>
+              <a:noFill/>
+            </p:spPr>
+            <p:txBody>
+              <a:bodyPr wrap="none" lIns="0" tIns="0" rIns="0" bIns="0" rtlCol="0">
+                <a:spAutoFit/>
+              </a:bodyPr>
+              <a:lstStyle/>
+              <a:p>
+                <a14:m>
+                  <m:oMathPara xmlns:m="http://schemas.openxmlformats.org/officeDocument/2006/math">
+                    <m:oMath>
+                      <m:d>
+                        <m:dPr>
+                          <m:ctrlPr>
+                            <a:rPr lang="en-US" altLang="ja-JP" sz="2400" i="1">
+                              <a:latin typeface="Cambria Math" panose="02040503050406030204" pitchFamily="18" charset="0"/>
+                            </a:rPr>
+                          </m:ctrlPr>
+                        </m:dPr>
+                        <m:e>
+                          <m:r>
+                            <a:rPr lang="en-US" altLang="ja-JP" sz="2400" i="1">
+                              <a:latin typeface="Cambria Math" panose="02040503050406030204" pitchFamily="18" charset="0"/>
+                            </a:rPr>
+                            <m:t>1−</m:t>
+                          </m:r>
+                          <m:r>
+                            <a:rPr lang="en-US" altLang="ja-JP" sz="2400" i="1">
+                              <a:latin typeface="Cambria Math" panose="02040503050406030204" pitchFamily="18" charset="0"/>
+                            </a:rPr>
+                            <m:t>𝜃</m:t>
+                          </m:r>
+                        </m:e>
+                      </m:d>
+                      <m:d>
+                        <m:dPr>
+                          <m:ctrlPr>
+                            <a:rPr lang="en-US" altLang="ja-JP" sz="2400" i="1">
+                              <a:latin typeface="Cambria Math" panose="02040503050406030204" pitchFamily="18" charset="0"/>
+                            </a:rPr>
+                          </m:ctrlPr>
+                        </m:dPr>
+                        <m:e>
+                          <m:f>
+                            <m:fPr>
+                              <m:ctrlPr>
+                                <a:rPr lang="en-US" altLang="ja-JP" sz="2400" i="1">
+                                  <a:latin typeface="Cambria Math" panose="02040503050406030204" pitchFamily="18" charset="0"/>
+                                </a:rPr>
+                              </m:ctrlPr>
+                            </m:fPr>
+                            <m:num>
+                              <m:sSub>
+                                <m:sSubPr>
+                                  <m:ctrlPr>
+                                    <a:rPr lang="en-US" altLang="ja-JP" sz="2400" i="1">
+                                      <a:latin typeface="Cambria Math" panose="02040503050406030204" pitchFamily="18" charset="0"/>
+                                    </a:rPr>
+                                  </m:ctrlPr>
+                                </m:sSubPr>
+                                <m:e>
+                                  <m:r>
+                                    <a:rPr lang="en-US" altLang="ja-JP" sz="2400" i="1">
+                                      <a:latin typeface="Cambria Math" panose="02040503050406030204" pitchFamily="18" charset="0"/>
+                                    </a:rPr>
+                                    <m:t>𝑅</m:t>
+                                  </m:r>
+                                </m:e>
+                                <m:sub>
+                                  <m:r>
+                                    <a:rPr lang="en-US" altLang="ja-JP" sz="2400" i="1">
+                                      <a:latin typeface="Cambria Math" panose="02040503050406030204" pitchFamily="18" charset="0"/>
+                                    </a:rPr>
+                                    <m:t>𝑡</m:t>
+                                  </m:r>
+                                </m:sub>
+                              </m:sSub>
+                              <m:r>
+                                <a:rPr lang="en-US" altLang="ja-JP" sz="2400" i="1">
+                                  <a:latin typeface="Cambria Math" panose="02040503050406030204" pitchFamily="18" charset="0"/>
+                                </a:rPr>
+                                <m:t>−</m:t>
+                              </m:r>
+                              <m:sSubSup>
+                                <m:sSubSupPr>
+                                  <m:ctrlPr>
+                                    <a:rPr lang="en-US" altLang="ja-JP" sz="2400" i="1">
+                                      <a:latin typeface="Cambria Math" panose="02040503050406030204" pitchFamily="18" charset="0"/>
+                                    </a:rPr>
+                                  </m:ctrlPr>
+                                </m:sSubSupPr>
+                                <m:e>
+                                  <m:r>
+                                    <a:rPr lang="en-US" altLang="ja-JP" sz="2400" i="1">
+                                      <a:latin typeface="Cambria Math" panose="02040503050406030204" pitchFamily="18" charset="0"/>
+                                    </a:rPr>
+                                    <m:t>𝑅</m:t>
+                                  </m:r>
+                                </m:e>
+                                <m:sub>
+                                  <m:r>
+                                    <a:rPr lang="en-US" altLang="ja-JP" sz="2400" i="1">
+                                      <a:latin typeface="Cambria Math" panose="02040503050406030204" pitchFamily="18" charset="0"/>
+                                    </a:rPr>
+                                    <m:t>𝑡</m:t>
+                                  </m:r>
+                                </m:sub>
+                                <m:sup>
+                                  <m:r>
+                                    <a:rPr lang="en-US" altLang="ja-JP" sz="2400" i="1">
+                                      <a:latin typeface="Cambria Math" panose="02040503050406030204" pitchFamily="18" charset="0"/>
+                                    </a:rPr>
+                                    <m:t>′</m:t>
+                                  </m:r>
+                                </m:sup>
+                              </m:sSubSup>
+                            </m:num>
+                            <m:den>
+                              <m:sSub>
+                                <m:sSubPr>
+                                  <m:ctrlPr>
+                                    <a:rPr lang="en-US" altLang="ja-JP" sz="2400" i="1">
+                                      <a:latin typeface="Cambria Math" panose="02040503050406030204" pitchFamily="18" charset="0"/>
+                                    </a:rPr>
+                                  </m:ctrlPr>
+                                </m:sSubPr>
+                                <m:e>
+                                  <m:r>
+                                    <a:rPr lang="en-US" altLang="ja-JP" sz="2400" i="1">
+                                      <a:latin typeface="Cambria Math" panose="02040503050406030204" pitchFamily="18" charset="0"/>
+                                    </a:rPr>
+                                    <m:t>𝜙</m:t>
+                                  </m:r>
+                                </m:e>
+                                <m:sub>
+                                  <m:r>
+                                    <a:rPr lang="en-US" altLang="ja-JP" sz="2400" i="1">
+                                      <a:latin typeface="Cambria Math" panose="02040503050406030204" pitchFamily="18" charset="0"/>
+                                    </a:rPr>
+                                    <m:t>𝑡</m:t>
+                                  </m:r>
+                                  <m:r>
+                                    <a:rPr lang="en-US" altLang="ja-JP" sz="2400" i="1">
+                                      <a:latin typeface="Cambria Math" panose="02040503050406030204" pitchFamily="18" charset="0"/>
+                                    </a:rPr>
+                                    <m:t>−1</m:t>
+                                  </m:r>
+                                </m:sub>
+                              </m:sSub>
+                            </m:den>
+                          </m:f>
+                          <m:r>
+                            <a:rPr lang="en-US" altLang="ja-JP" sz="2400" i="1">
+                              <a:latin typeface="Cambria Math" panose="02040503050406030204" pitchFamily="18" charset="0"/>
+                            </a:rPr>
+                            <m:t>+</m:t>
+                          </m:r>
+                          <m:sSubSup>
+                            <m:sSubSupPr>
+                              <m:ctrlPr>
+                                <a:rPr lang="en-US" altLang="ja-JP" sz="2400" i="1">
+                                  <a:latin typeface="Cambria Math" panose="02040503050406030204" pitchFamily="18" charset="0"/>
+                                </a:rPr>
+                              </m:ctrlPr>
+                            </m:sSubSupPr>
+                            <m:e>
+                              <m:r>
+                                <a:rPr lang="en-US" altLang="ja-JP" sz="2400" i="1">
+                                  <a:latin typeface="Cambria Math" panose="02040503050406030204" pitchFamily="18" charset="0"/>
+                                </a:rPr>
+                                <m:t>𝑅</m:t>
+                              </m:r>
+                            </m:e>
+                            <m:sub>
+                              <m:r>
+                                <a:rPr lang="en-US" altLang="ja-JP" sz="2400" i="1">
+                                  <a:latin typeface="Cambria Math" panose="02040503050406030204" pitchFamily="18" charset="0"/>
+                                </a:rPr>
+                                <m:t>𝑡</m:t>
+                              </m:r>
+                            </m:sub>
+                            <m:sup>
+                              <m:r>
+                                <a:rPr lang="en-US" altLang="ja-JP" sz="2400" i="1">
+                                  <a:latin typeface="Cambria Math" panose="02040503050406030204" pitchFamily="18" charset="0"/>
+                                </a:rPr>
+                                <m:t>′</m:t>
+                              </m:r>
+                            </m:sup>
+                          </m:sSubSup>
+                        </m:e>
+                      </m:d>
+                      <m:sSub>
+                        <m:sSubPr>
+                          <m:ctrlPr>
+                            <a:rPr lang="en-US" altLang="ja-JP" sz="2400" i="1">
+                              <a:latin typeface="Cambria Math" panose="02040503050406030204" pitchFamily="18" charset="0"/>
+                            </a:rPr>
+                          </m:ctrlPr>
+                        </m:sSubPr>
+                        <m:e>
+                          <m:r>
+                            <a:rPr lang="en-US" altLang="ja-JP" sz="2400" i="1">
+                              <a:latin typeface="Cambria Math" panose="02040503050406030204" pitchFamily="18" charset="0"/>
+                            </a:rPr>
+                            <m:t>𝑁</m:t>
+                          </m:r>
+                        </m:e>
+                        <m:sub>
+                          <m:r>
+                            <a:rPr lang="en-US" altLang="ja-JP" sz="2400" i="1">
+                              <a:latin typeface="Cambria Math" panose="02040503050406030204" pitchFamily="18" charset="0"/>
+                            </a:rPr>
+                            <m:t>𝑡</m:t>
+                          </m:r>
+                          <m:r>
+                            <a:rPr lang="en-US" altLang="ja-JP" sz="2400" i="1">
+                              <a:latin typeface="Cambria Math" panose="02040503050406030204" pitchFamily="18" charset="0"/>
+                            </a:rPr>
+                            <m:t>−1</m:t>
+                          </m:r>
+                        </m:sub>
+                      </m:sSub>
+                    </m:oMath>
+                  </m:oMathPara>
+                </a14:m>
+                <a:endParaRPr lang="en-US" altLang="ja-JP" sz="2400" dirty="0"/>
+              </a:p>
+              <a:p>
+                <a:endParaRPr kumimoji="1" lang="ja-JP" altLang="en-US" sz="2400" dirty="0"/>
+              </a:p>
+            </p:txBody>
+          </p:sp>
+        </mc:Choice>
+        <mc:Fallback>
+          <p:sp>
+            <p:nvSpPr>
+              <p:cNvPr id="2" name="テキスト ボックス 1">
+                <a:extLst>
+                  <a:ext uri="{FF2B5EF4-FFF2-40B4-BE49-F238E27FC236}">
+                    <a16:creationId xmlns:a16="http://schemas.microsoft.com/office/drawing/2014/main" id="{ECCC5459-23EA-3FBF-3252-BF94DE2A3259}"/>
+                  </a:ext>
+                </a:extLst>
+              </p:cNvPr>
+              <p:cNvSpPr txBox="1">
+                <a:spLocks noRot="1" noChangeAspect="1" noMove="1" noResize="1" noEditPoints="1" noAdjustHandles="1" noChangeArrowheads="1" noChangeShapeType="1" noTextEdit="1"/>
+              </p:cNvSpPr>
+              <p:nvPr/>
+            </p:nvSpPr>
+            <p:spPr>
+              <a:xfrm>
+                <a:off x="6385915" y="4375352"/>
+                <a:ext cx="3943002" cy="1199174"/>
+              </a:xfrm>
+              <a:prstGeom prst="rect">
+                <a:avLst/>
+              </a:prstGeom>
+              <a:blipFill>
+                <a:blip r:embed="rId8"/>
+                <a:stretch>
+                  <a:fillRect/>
+                </a:stretch>
+              </a:blipFill>
+            </p:spPr>
+            <p:txBody>
+              <a:bodyPr/>
+              <a:lstStyle/>
+              <a:p>
+                <a:r>
+                  <a:rPr lang="ja-JP" altLang="en-US">
+                    <a:noFill/>
+                  </a:rPr>
+                  <a:t> </a:t>
+                </a:r>
+              </a:p>
+            </p:txBody>
+          </p:sp>
+        </mc:Fallback>
+      </mc:AlternateContent>
     </p:spTree>
     <p:extLst>
       <p:ext uri="{BB962C8B-B14F-4D97-AF65-F5344CB8AC3E}">

</xml_diff>